<commit_message>
Use public CRUD simulation and training WebView
</commit_message>
<xml_diff>
--- a/Hari_3_Flutter_Professional.pptx
+++ b/Hari_3_Flutter_Professional.pptx
@@ -2714,7 +2714,7 @@
           <a:p/>
           <a:p>
             <a:r>
-              <a:t>ARAHAN TRAINER: Tegaskan demo local-first dan JS-off.</a:t>
+              <a:t>ARAHAN TRAINER: Tegaskan satu situs HTTPS, exact-host allowlist, dan tanpa JS bridge.</a:t>
             </a:r>
           </a:p>
           <a:p/>
@@ -2996,13 +2996,13 @@
           <a:p/>
           <a:p>
             <a:r>
-              <a:t>ARAHAN TRAINER: Jalankan unit test file/about/https/javascript lalu demo external block.</a:t>
+              <a:t>ARAHAN TRAINER: Jalankan unit test untuk dua host, HTTP, fake subdomain, file, dan javascript.</a:t>
             </a:r>
           </a:p>
           <a:p/>
           <a:p>
             <a:r>
-              <a:t>PERTANYAAN DISKUSI: Risiko apa muncul dari JS bridge?</a:t>
+              <a:t>PERTANYAAN DISKUSI: Mengapa pencocokan string URL berbahaya?</a:t>
             </a:r>
           </a:p>
           <a:p/>
@@ -19004,7 +19004,7 @@
               <a:rPr>
                 <a:latin typeface="Aptos"/>
               </a:rPr>
-              <a:t>•  Local asset</a:t>
+              <a:t>•  Situs latihan</a:t>
             </a:r>
           </a:p>
           <a:p>
@@ -19023,7 +19023,7 @@
               <a:rPr>
                 <a:latin typeface="Aptos"/>
               </a:rPr>
-              <a:t>•  JS off + block</a:t>
+              <a:t>•  HTTPS allowlist</a:t>
             </a:r>
           </a:p>
         </p:txBody>
@@ -28543,7 +28543,7 @@
               <a:rPr>
                 <a:latin typeface="Aptos"/>
               </a:rPr>
-              <a:t>•  No JS relaxation</a:t>
+              <a:t>•  No host/bridge expansion</a:t>
             </a:r>
           </a:p>
           <a:p>
@@ -33843,7 +33843,7 @@
                 </a:solidFill>
                 <a:latin typeface="Aptos"/>
               </a:rPr>
-              <a:t>Load local asset</a:t>
+              <a:t>Load training site</a:t>
             </a:r>
           </a:p>
         </p:txBody>
@@ -34482,8 +34482,8 @@
 │   └── migration_webview_controller.dart
 └── screens/
     └── training_webview_screen.dart
-assets/
-└── migration_guide.html</a:t>
+URL:
+https://www.presisirencar.com/</a:t>
             </a:r>
           </a:p>
         </p:txBody>
@@ -35290,7 +35290,7 @@
                 </a:solidFill>
                 <a:latin typeface="Aptos Display"/>
               </a:rPr>
-              <a:t>Controller: local-first dan JavaScript off</a:t>
+              <a:t>Controller: satu URL, state jelas</a:t>
             </a:r>
           </a:p>
         </p:txBody>
@@ -35567,15 +35567,17 @@
               </a:spcAft>
             </a:pPr>
             <a:r>
-              <a:rPr sz="1200" b="0">
+              <a:rPr sz="1130" b="0">
                 <a:solidFill>
                   <a:srgbClr val="D9ECF5"/>
                 </a:solidFill>
                 <a:latin typeface="Cascadia Mono"/>
               </a:rPr>
-              <a:t>return WebViewController()
+              <a:t>const trainingWebsiteUrl =
+  'https://www.presisirencar.com/';
+return WebViewController()
   ..setJavaScriptMode(
-    JavaScriptMode.disabled,
+    JavaScriptMode.unrestricted,
   )
   ..setNavigationDelegate(
     NavigationDelegate(
@@ -35584,8 +35586,8 @@
       onWebResourceError: handleError,
     ),
   )
-  ..loadFlutterAsset(
-    'assets/migration_guide.html',
+  ..loadRequest(
+    Uri.parse(trainingWebsiteUrl),
   );</a:t>
             </a:r>
           </a:p>
@@ -35625,7 +35627,7 @@
                 </a:solidFill>
                 <a:latin typeface="Aptos"/>
               </a:rPr>
-              <a:t>LOCAL ASSET • JS OFF</a:t>
+              <a:t>ONE URL • NO JS BRIDGE</a:t>
             </a:r>
           </a:p>
         </p:txBody>
@@ -35834,7 +35836,7 @@
                 </a:solidFill>
                 <a:latin typeface="Aptos"/>
               </a:rPr>
-              <a:t>Reproducible</a:t>
+              <a:t>Keputusan</a:t>
             </a:r>
           </a:p>
         </p:txBody>
@@ -35876,7 +35878,7 @@
               <a:rPr>
                 <a:latin typeface="Aptos"/>
               </a:rPr>
-              <a:t>•  HTML versioned</a:t>
+              <a:t>•  HTTPS only</a:t>
             </a:r>
           </a:p>
           <a:p>
@@ -35895,7 +35897,7 @@
               <a:rPr>
                 <a:latin typeface="Aptos"/>
               </a:rPr>
-              <a:t>•  No network</a:t>
+              <a:t>•  JS untuk Next.js</a:t>
             </a:r>
           </a:p>
           <a:p>
@@ -35914,7 +35916,7 @@
               <a:rPr>
                 <a:latin typeface="Aptos"/>
               </a:rPr>
-              <a:t>•  Known content</a:t>
+              <a:t>•  No JS bridge</a:t>
             </a:r>
           </a:p>
         </p:txBody>
@@ -36412,7 +36414,7 @@
                 </a:solidFill>
                 <a:latin typeface="Aptos Display"/>
               </a:rPr>
-              <a:t>Default deny: hanya file dan about:blank</a:t>
+              <a:t>Default deny: HTTPS + exact host</a:t>
             </a:r>
           </a:p>
         </p:txBody>
@@ -36689,22 +36691,26 @@
               </a:spcAft>
             </a:pPr>
             <a:r>
-              <a:rPr sz="1230" b="0">
+              <a:rPr sz="1080" b="0">
                 <a:solidFill>
                   <a:srgbClr val="D9ECF5"/>
                 </a:solidFill>
                 <a:latin typeface="Cascadia Mono"/>
               </a:rPr>
-              <a:t>abstract final class TrainingNavigationPolicy {
-  static bool allows(String rawUrl) {
-    if (rawUrl == 'about:blank') {
-      return true;
-    }
-    final uri = Uri.tryParse(rawUrl);
-    return uri?.scheme == 'file';
-  }
+              <a:t>static const allowedHosts = {
+  'presisirencar.com',
+  'www.presisirencar.com',
+};
+static bool allows(String rawUrl) {
+  if (rawUrl == 'about:blank') return true;
+  final uri = Uri.tryParse(rawUrl);
+  return uri != null &amp;&amp;
+      uri.scheme == 'https' &amp;&amp;
+      allowedHosts.contains(
+        uri.host.toLowerCase(),
+      );
 }
-// https:, javascript:, invalid → false</a:t>
+// http, file, javascript, external → false</a:t>
             </a:r>
           </a:p>
         </p:txBody>
@@ -36994,7 +37000,7 @@
               <a:rPr>
                 <a:latin typeface="Aptos"/>
               </a:rPr>
-              <a:t>•  file/about only</a:t>
+              <a:t>•  2 exact hosts</a:t>
             </a:r>
           </a:p>
           <a:p>
@@ -37241,7 +37247,7 @@
                 </a:solidFill>
                 <a:latin typeface="Aptos"/>
               </a:rPr>
-              <a:t>Jika produksi</a:t>
+              <a:t>Test negatif</a:t>
             </a:r>
           </a:p>
         </p:txBody>
@@ -37283,7 +37289,7 @@
               <a:rPr>
                 <a:latin typeface="Aptos"/>
               </a:rPr>
-              <a:t>•  Exact HTTPS allowlist</a:t>
+              <a:t>•  HTTP</a:t>
             </a:r>
           </a:p>
           <a:p>
@@ -37302,7 +37308,7 @@
               <a:rPr>
                 <a:latin typeface="Aptos"/>
               </a:rPr>
-              <a:t>•  Session/logout policy</a:t>
+              <a:t>•  Fake subdomain</a:t>
             </a:r>
           </a:p>
           <a:p>
@@ -37321,7 +37327,7 @@
               <a:rPr>
                 <a:latin typeface="Aptos"/>
               </a:rPr>
-              <a:t>•  Threat review + tests</a:t>
+              <a:t>•  file/javascript</a:t>
             </a:r>
           </a:p>
         </p:txBody>
@@ -39149,7 +39155,7 @@
               <a:rPr>
                 <a:latin typeface="Aptos"/>
               </a:rPr>
-              <a:t>•  Load local asset</a:t>
+              <a:t>•  Load presisirencar.com</a:t>
             </a:r>
           </a:p>
           <a:p>
@@ -39187,7 +39193,7 @@
               <a:rPr>
                 <a:latin typeface="Aptos"/>
               </a:rPr>
-              <a:t>•  JS tetap off</a:t>
+              <a:t>•  Apply HTTPS allowlist</a:t>
             </a:r>
           </a:p>
           <a:p>
@@ -39495,7 +39501,7 @@
               <a:rPr>
                 <a:latin typeface="Aptos"/>
               </a:rPr>
-              <a:t>•  Asset tampil</a:t>
+              <a:t>•  Site tampil</a:t>
             </a:r>
           </a:p>
           <a:p>
@@ -39784,7 +39790,7 @@
               <a:rPr>
                 <a:latin typeface="Aptos"/>
               </a:rPr>
-              <a:t>•  Add host allowlist tests</a:t>
+              <a:t>•  Test fake subdomain</a:t>
             </a:r>
           </a:p>
           <a:p>
@@ -39803,7 +39809,7 @@
               <a:rPr>
                 <a:latin typeface="Aptos"/>
               </a:rPr>
-              <a:t>•  Document remote rollout</a:t>
+              <a:t>•  Document session policy</a:t>
             </a:r>
           </a:p>
         </p:txBody>
@@ -42457,7 +42463,7 @@
                         </a:defRPr>
                       </a:pPr>
                       <a:r>
-                        <a:t>local + external denied</a:t>
+                        <a:t>site + external denied</a:t>
                       </a:r>
                     </a:p>
                   </a:txBody>
@@ -42728,7 +42734,7 @@
                 </a:solidFill>
                 <a:latin typeface="Aptos"/>
               </a:rPr>
-              <a:t>Core harus lulus sebelum stretch: remote WebView, bridge, atau slice kedua.</a:t>
+              <a:t>Core harus lulus sebelum stretch: session/login, bridge, atau slice kedua.</a:t>
             </a:r>
           </a:p>
         </p:txBody>

</xml_diff>